<commit_message>
style: professional visual redesign of renderer and template theme
- Add centralized theme.ts with cohesive color palette and typography
- Title slides: dark navy background, centered layout, accent line
- Section slides: vibrant blue background, left accent bar
- Content slides: light background, navy titles, accent underbar
- Bullets: themed bullet characters, proper line spacing
- Two columns: vertical divider, dual-accent bullet colors
- Timeline: white-bordered circles, dashed connectors, themed colors
- Architecture: layer labels, color-coded backgrounds, clean nodes
- Template theme: updated accent palette and Calibri Light titles

Co-Authored-By: Claude Opus 4.6 (1M context) <noreply@anthropic.com>
</commit_message>
<xml_diff>
--- a/pptx-generator/assets/default-template.pptx
+++ b/pptx-generator/assets/default-template.pptx
@@ -477,38 +477,38 @@
 </file>
 
 <file path=ppt/theme/theme1.xml><?xml version="1.0" encoding="utf-8"?>
-<a:theme xmlns:a="http://schemas.openxmlformats.org/drawingml/2006/main" name="DefaultTheme">
+<a:theme xmlns:a="http://schemas.openxmlformats.org/drawingml/2006/main" name="Professional">
   <a:themeElements>
-    <a:clrScheme name="DefaultColors">
+    <a:clrScheme name="Professional">
       <a:dk1>
-        <a:srgbClr val="000000"/>
+        <a:srgbClr val="1B2A4A"/>
       </a:dk1>
       <a:lt1>
         <a:srgbClr val="FFFFFF"/>
       </a:lt1>
       <a:dk2>
-        <a:srgbClr val="44546A"/>
+        <a:srgbClr val="2C3E50"/>
       </a:dk2>
       <a:lt2>
-        <a:srgbClr val="E7E6E6"/>
+        <a:srgbClr val="F7F9FC"/>
       </a:lt2>
       <a:accent1>
-        <a:srgbClr val="1F4E79"/>
+        <a:srgbClr val="1B2A4A"/>
       </a:accent1>
       <a:accent2>
-        <a:srgbClr val="2E75B6"/>
+        <a:srgbClr val="2D7DD2"/>
       </a:accent2>
       <a:accent3>
-        <a:srgbClr val="C00000"/>
+        <a:srgbClr val="17A2B8"/>
       </a:accent3>
       <a:accent4>
-        <a:srgbClr val="2E7D32"/>
+        <a:srgbClr val="E8625C"/>
       </a:accent4>
       <a:accent5>
-        <a:srgbClr val="6A1B9A"/>
+        <a:srgbClr val="27AE60"/>
       </a:accent5>
       <a:accent6>
-        <a:srgbClr val="E65100"/>
+        <a:srgbClr val="F39C12"/>
       </a:accent6>
       <a:hlink>
         <a:srgbClr val="0563C1"/>
@@ -517,9 +517,9 @@
         <a:srgbClr val="954F72"/>
       </a:folHlink>
     </a:clrScheme>
-    <a:fontScheme name="DefaultFonts">
+    <a:fontScheme name="ProfessionalFonts">
       <a:majorFont>
-        <a:latin typeface="Calibri"/>
+        <a:latin typeface="Calibri Light"/>
         <a:ea typeface=""/>
         <a:cs typeface=""/>
       </a:majorFont>

</xml_diff>

<commit_message>
feat: enhance default template with professional styling and update capabilities
- Updated the default template to include professional visual styles, including background colors, text styles, and bullet formatting.
- Revised the TODO.md to reflect the completion of the professional template task.
- Modified the capabilities manifest to reflect the new template generation date.
- Refactored buildDefaultTemplate.ts to improve shape creation with optional text styling and added accent lines for visual separation.
- Updated the SKILL.md documentation to reflect changes in the AST generation process.
- Removed validation from the CLI for AST input, simplifying the process.
- Introduced constants for layout types and fallback cascades to improve code organization.
- Updated tests to ensure compatibility with new module imports and structure.
</commit_message>
<xml_diff>
--- a/pptx-generator/assets/default-template.pptx
+++ b/pptx-generator/assets/default-template.pptx
@@ -12,6 +12,14 @@
 <file path=ppt/slideLayouts/slideLayout1.xml><?xml version="1.0" encoding="utf-8"?>
 <p:sldLayout xmlns:a="http://schemas.openxmlformats.org/drawingml/2006/main" xmlns:r="http://schemas.openxmlformats.org/officeDocument/2006/relationships" xmlns:p="http://schemas.openxmlformats.org/presentationml/2006/main" type="obj" preserve="1">
   <p:cSld name="LAYOUT_TITLE">
+    <p:bg>
+      <p:bgPr>
+        <a:solidFill>
+          <a:srgbClr val="1B2A4A"/>
+        </a:solidFill>
+        <a:effectLst/>
+      </p:bgPr>
+    </p:bg>
     <p:spTree>
       <p:nvGrpSpPr>
         <p:cNvPr id="1" name=""/>
@@ -43,10 +51,16 @@
           </a:xfrm>
         </p:spPr>
         <p:txBody>
-          <a:bodyPr/>
-          <a:lstStyle/>
-          <a:p>
-            <a:endParaRPr lang="en-US"/>
+          <a:bodyPr anchor="b"/>
+          <a:lstStyle/>
+          <a:p>
+            <a:pPr algn="ctr"/>
+            <a:endParaRPr lang="en-US" sz="4400" b="1">
+              <a:solidFill>
+                <a:srgbClr val="FFFFFF"/>
+              </a:solidFill>
+              <a:latin typeface="+mj-lt"/>
+            </a:endParaRPr>
           </a:p>
         </p:txBody>
       </p:sp>
@@ -67,10 +81,16 @@
           </a:xfrm>
         </p:spPr>
         <p:txBody>
-          <a:bodyPr/>
-          <a:lstStyle/>
-          <a:p>
-            <a:endParaRPr lang="en-US"/>
+          <a:bodyPr anchor="t"/>
+          <a:lstStyle/>
+          <a:p>
+            <a:pPr algn="ctr"/>
+            <a:endParaRPr lang="en-US" sz="2000">
+              <a:solidFill>
+                <a:srgbClr val="B8C6D9"/>
+              </a:solidFill>
+              <a:latin typeface="+mn-lt"/>
+            </a:endParaRPr>
           </a:p>
         </p:txBody>
       </p:sp>
@@ -82,6 +102,14 @@
 <file path=ppt/slideLayouts/slideLayout2.xml><?xml version="1.0" encoding="utf-8"?>
 <p:sldLayout xmlns:a="http://schemas.openxmlformats.org/drawingml/2006/main" xmlns:r="http://schemas.openxmlformats.org/officeDocument/2006/relationships" xmlns:p="http://schemas.openxmlformats.org/presentationml/2006/main" type="obj" preserve="1">
   <p:cSld name="LAYOUT_SECTION">
+    <p:bg>
+      <p:bgPr>
+        <a:solidFill>
+          <a:srgbClr val="2D7DD2"/>
+        </a:solidFill>
+        <a:effectLst/>
+      </p:bgPr>
+    </p:bg>
     <p:spTree>
       <p:nvGrpSpPr>
         <p:cNvPr id="1" name=""/>
@@ -108,15 +136,21 @@
         </p:nvSpPr>
         <p:spPr>
           <a:xfrm>
-            <a:off x="457200" y="457200"/>
-            <a:ext cx="11277600" cy="1143000"/>
-          </a:xfrm>
-        </p:spPr>
-        <p:txBody>
-          <a:bodyPr/>
-          <a:lstStyle/>
-          <a:p>
-            <a:endParaRPr lang="en-US"/>
+            <a:off x="457200" y="1943100"/>
+            <a:ext cx="11277600" cy="1600200"/>
+          </a:xfrm>
+        </p:spPr>
+        <p:txBody>
+          <a:bodyPr anchor="b"/>
+          <a:lstStyle/>
+          <a:p>
+            <a:pPr algn="l"/>
+            <a:endParaRPr lang="en-US" sz="3200" b="1">
+              <a:solidFill>
+                <a:srgbClr val="FFFFFF"/>
+              </a:solidFill>
+              <a:latin typeface="+mj-lt"/>
+            </a:endParaRPr>
           </a:p>
         </p:txBody>
       </p:sp>
@@ -132,15 +166,21 @@
         </p:nvSpPr>
         <p:spPr>
           <a:xfrm>
-            <a:off x="457200" y="2057400"/>
-            <a:ext cx="11277600" cy="4343400"/>
-          </a:xfrm>
-        </p:spPr>
-        <p:txBody>
-          <a:bodyPr/>
-          <a:lstStyle/>
-          <a:p>
-            <a:endParaRPr lang="en-US"/>
+            <a:off x="457200" y="4000500"/>
+            <a:ext cx="11277600" cy="914400"/>
+          </a:xfrm>
+        </p:spPr>
+        <p:txBody>
+          <a:bodyPr anchor="t"/>
+          <a:lstStyle/>
+          <a:p>
+            <a:pPr algn="l"/>
+            <a:endParaRPr lang="en-US" sz="1800">
+              <a:solidFill>
+                <a:srgbClr val="D4E6F1"/>
+              </a:solidFill>
+              <a:latin typeface="+mn-lt"/>
+            </a:endParaRPr>
           </a:p>
         </p:txBody>
       </p:sp>
@@ -152,6 +192,14 @@
 <file path=ppt/slideLayouts/slideLayout3.xml><?xml version="1.0" encoding="utf-8"?>
 <p:sldLayout xmlns:a="http://schemas.openxmlformats.org/drawingml/2006/main" xmlns:r="http://schemas.openxmlformats.org/officeDocument/2006/relationships" xmlns:p="http://schemas.openxmlformats.org/presentationml/2006/main" type="obj" preserve="1">
   <p:cSld name="LAYOUT_BULLETS">
+    <p:bg>
+      <p:bgPr>
+        <a:solidFill>
+          <a:srgbClr val="F7F9FC"/>
+        </a:solidFill>
+        <a:effectLst/>
+      </p:bgPr>
+    </p:bg>
     <p:spTree>
       <p:nvGrpSpPr>
         <p:cNvPr id="1" name=""/>
@@ -183,12 +231,39 @@
           </a:xfrm>
         </p:spPr>
         <p:txBody>
-          <a:bodyPr/>
-          <a:lstStyle/>
-          <a:p>
-            <a:endParaRPr lang="en-US"/>
-          </a:p>
-        </p:txBody>
+          <a:bodyPr anchor="b"/>
+          <a:lstStyle/>
+          <a:p>
+            <a:pPr algn="l"/>
+            <a:endParaRPr lang="en-US" sz="2800" b="1">
+              <a:solidFill>
+                <a:srgbClr val="1B2A4A"/>
+              </a:solidFill>
+              <a:latin typeface="+mj-lt"/>
+            </a:endParaRPr>
+          </a:p>
+        </p:txBody>
+      </p:sp>
+      <p:sp>
+        <p:nvSpPr>
+          <p:cNvPr id="5" name="Accent Line"/>
+          <p:cNvSpPr/>
+          <p:nvPr/>
+        </p:nvSpPr>
+        <p:spPr>
+          <a:xfrm>
+            <a:off x="457200" y="1828800"/>
+            <a:ext cx="11277600" cy="0"/>
+          </a:xfrm>
+          <a:prstGeom prst="line">
+            <a:avLst/>
+          </a:prstGeom>
+          <a:ln w="28575">
+            <a:solidFill>
+              <a:srgbClr val="2D7DD2"/>
+            </a:solidFill>
+          </a:ln>
+        </p:spPr>
       </p:sp>
       <p:sp>
         <p:nvSpPr>
@@ -207,10 +282,30 @@
           </a:xfrm>
         </p:spPr>
         <p:txBody>
-          <a:bodyPr/>
-          <a:lstStyle/>
-          <a:p>
-            <a:endParaRPr lang="en-US"/>
+          <a:bodyPr anchor="t"/>
+          <a:lstStyle>
+            <a:lvl1pPr marL="342900" indent="-342900">
+              <a:buSzPct val="100000"/>
+              <a:buFont typeface="Arial" panose="020B0604020202020204"/>
+              <a:buClr>
+                <a:srgbClr val="2D7DD2"/>
+              </a:buClr>
+              <a:buChar char="•"/>
+              <a:defRPr sz="1600">
+                <a:solidFill>
+                  <a:srgbClr val="2C3E50"/>
+                </a:solidFill>
+                <a:latin typeface="+mn-lt"/>
+              </a:defRPr>
+            </a:lvl1pPr>
+          </a:lstStyle>
+          <a:p>
+            <a:endParaRPr lang="en-US" sz="1600">
+              <a:solidFill>
+                <a:srgbClr val="2C3E50"/>
+              </a:solidFill>
+              <a:latin typeface="+mn-lt"/>
+            </a:endParaRPr>
           </a:p>
         </p:txBody>
       </p:sp>
@@ -222,6 +317,14 @@
 <file path=ppt/slideLayouts/slideLayout4.xml><?xml version="1.0" encoding="utf-8"?>
 <p:sldLayout xmlns:a="http://schemas.openxmlformats.org/drawingml/2006/main" xmlns:r="http://schemas.openxmlformats.org/officeDocument/2006/relationships" xmlns:p="http://schemas.openxmlformats.org/presentationml/2006/main" type="obj" preserve="1">
   <p:cSld name="LAYOUT_GENERIC">
+    <p:bg>
+      <p:bgPr>
+        <a:solidFill>
+          <a:srgbClr val="F7F9FC"/>
+        </a:solidFill>
+        <a:effectLst/>
+      </p:bgPr>
+    </p:bg>
     <p:spTree>
       <p:nvGrpSpPr>
         <p:cNvPr id="1" name=""/>
@@ -253,12 +356,39 @@
           </a:xfrm>
         </p:spPr>
         <p:txBody>
-          <a:bodyPr/>
-          <a:lstStyle/>
-          <a:p>
-            <a:endParaRPr lang="en-US"/>
-          </a:p>
-        </p:txBody>
+          <a:bodyPr anchor="b"/>
+          <a:lstStyle/>
+          <a:p>
+            <a:pPr algn="l"/>
+            <a:endParaRPr lang="en-US" sz="2800" b="1">
+              <a:solidFill>
+                <a:srgbClr val="1B2A4A"/>
+              </a:solidFill>
+              <a:latin typeface="+mj-lt"/>
+            </a:endParaRPr>
+          </a:p>
+        </p:txBody>
+      </p:sp>
+      <p:sp>
+        <p:nvSpPr>
+          <p:cNvPr id="5" name="Accent Line"/>
+          <p:cNvSpPr/>
+          <p:nvPr/>
+        </p:nvSpPr>
+        <p:spPr>
+          <a:xfrm>
+            <a:off x="457200" y="1828800"/>
+            <a:ext cx="11277600" cy="0"/>
+          </a:xfrm>
+          <a:prstGeom prst="line">
+            <a:avLst/>
+          </a:prstGeom>
+          <a:ln w="28575">
+            <a:solidFill>
+              <a:srgbClr val="2D7DD2"/>
+            </a:solidFill>
+          </a:ln>
+        </p:spPr>
       </p:sp>
       <p:sp>
         <p:nvSpPr>
@@ -277,10 +407,15 @@
           </a:xfrm>
         </p:spPr>
         <p:txBody>
-          <a:bodyPr/>
-          <a:lstStyle/>
-          <a:p>
-            <a:endParaRPr lang="en-US"/>
+          <a:bodyPr anchor="t"/>
+          <a:lstStyle/>
+          <a:p>
+            <a:endParaRPr lang="en-US" sz="1600">
+              <a:solidFill>
+                <a:srgbClr val="2C3E50"/>
+              </a:solidFill>
+              <a:latin typeface="+mn-lt"/>
+            </a:endParaRPr>
           </a:p>
         </p:txBody>
       </p:sp>
@@ -292,6 +427,14 @@
 <file path=ppt/slideLayouts/slideLayout5.xml><?xml version="1.0" encoding="utf-8"?>
 <p:sldLayout xmlns:a="http://schemas.openxmlformats.org/drawingml/2006/main" xmlns:r="http://schemas.openxmlformats.org/officeDocument/2006/relationships" xmlns:p="http://schemas.openxmlformats.org/presentationml/2006/main" type="obj" preserve="1">
   <p:cSld name="LAYOUT_TWO_COLUMNS">
+    <p:bg>
+      <p:bgPr>
+        <a:solidFill>
+          <a:srgbClr val="F7F9FC"/>
+        </a:solidFill>
+        <a:effectLst/>
+      </p:bgPr>
+    </p:bg>
     <p:spTree>
       <p:nvGrpSpPr>
         <p:cNvPr id="1" name=""/>
@@ -323,12 +466,39 @@
           </a:xfrm>
         </p:spPr>
         <p:txBody>
-          <a:bodyPr/>
-          <a:lstStyle/>
-          <a:p>
-            <a:endParaRPr lang="en-US"/>
-          </a:p>
-        </p:txBody>
+          <a:bodyPr anchor="b"/>
+          <a:lstStyle/>
+          <a:p>
+            <a:pPr algn="l"/>
+            <a:endParaRPr lang="en-US" sz="2800" b="1">
+              <a:solidFill>
+                <a:srgbClr val="1B2A4A"/>
+              </a:solidFill>
+              <a:latin typeface="+mj-lt"/>
+            </a:endParaRPr>
+          </a:p>
+        </p:txBody>
+      </p:sp>
+      <p:sp>
+        <p:nvSpPr>
+          <p:cNvPr id="6" name="Accent Line"/>
+          <p:cNvSpPr/>
+          <p:nvPr/>
+        </p:nvSpPr>
+        <p:spPr>
+          <a:xfrm>
+            <a:off x="457200" y="1828800"/>
+            <a:ext cx="11277600" cy="0"/>
+          </a:xfrm>
+          <a:prstGeom prst="line">
+            <a:avLst/>
+          </a:prstGeom>
+          <a:ln w="28575">
+            <a:solidFill>
+              <a:srgbClr val="2D7DD2"/>
+            </a:solidFill>
+          </a:ln>
+        </p:spPr>
       </p:sp>
       <p:sp>
         <p:nvSpPr>
@@ -347,10 +517,30 @@
           </a:xfrm>
         </p:spPr>
         <p:txBody>
-          <a:bodyPr/>
-          <a:lstStyle/>
-          <a:p>
-            <a:endParaRPr lang="en-US"/>
+          <a:bodyPr anchor="t"/>
+          <a:lstStyle>
+            <a:lvl1pPr marL="342900" indent="-342900">
+              <a:buSzPct val="100000"/>
+              <a:buFont typeface="Arial" panose="020B0604020202020204"/>
+              <a:buClr>
+                <a:srgbClr val="2D7DD2"/>
+              </a:buClr>
+              <a:buChar char="•"/>
+              <a:defRPr sz="1600">
+                <a:solidFill>
+                  <a:srgbClr val="2C3E50"/>
+                </a:solidFill>
+                <a:latin typeface="+mn-lt"/>
+              </a:defRPr>
+            </a:lvl1pPr>
+          </a:lstStyle>
+          <a:p>
+            <a:endParaRPr lang="en-US" sz="1600">
+              <a:solidFill>
+                <a:srgbClr val="2C3E50"/>
+              </a:solidFill>
+              <a:latin typeface="+mn-lt"/>
+            </a:endParaRPr>
           </a:p>
         </p:txBody>
       </p:sp>
@@ -371,10 +561,30 @@
           </a:xfrm>
         </p:spPr>
         <p:txBody>
-          <a:bodyPr/>
-          <a:lstStyle/>
-          <a:p>
-            <a:endParaRPr lang="en-US"/>
+          <a:bodyPr anchor="t"/>
+          <a:lstStyle>
+            <a:lvl1pPr marL="342900" indent="-342900">
+              <a:buSzPct val="100000"/>
+              <a:buFont typeface="Arial" panose="020B0604020202020204"/>
+              <a:buClr>
+                <a:srgbClr val="2D7DD2"/>
+              </a:buClr>
+              <a:buChar char="•"/>
+              <a:defRPr sz="1600">
+                <a:solidFill>
+                  <a:srgbClr val="2C3E50"/>
+                </a:solidFill>
+                <a:latin typeface="+mn-lt"/>
+              </a:defRPr>
+            </a:lvl1pPr>
+          </a:lstStyle>
+          <a:p>
+            <a:endParaRPr lang="en-US" sz="1600">
+              <a:solidFill>
+                <a:srgbClr val="2C3E50"/>
+              </a:solidFill>
+              <a:latin typeface="+mn-lt"/>
+            </a:endParaRPr>
           </a:p>
         </p:txBody>
       </p:sp>
@@ -386,6 +596,14 @@
 <file path=ppt/slideLayouts/slideLayout6.xml><?xml version="1.0" encoding="utf-8"?>
 <p:sldLayout xmlns:a="http://schemas.openxmlformats.org/drawingml/2006/main" xmlns:r="http://schemas.openxmlformats.org/officeDocument/2006/relationships" xmlns:p="http://schemas.openxmlformats.org/presentationml/2006/main" type="obj" preserve="1">
   <p:cSld name="LAYOUT_TIMELINE">
+    <p:bg>
+      <p:bgPr>
+        <a:solidFill>
+          <a:srgbClr val="F7F9FC"/>
+        </a:solidFill>
+        <a:effectLst/>
+      </p:bgPr>
+    </p:bg>
     <p:spTree>
       <p:nvGrpSpPr>
         <p:cNvPr id="1" name=""/>
@@ -417,12 +635,39 @@
           </a:xfrm>
         </p:spPr>
         <p:txBody>
-          <a:bodyPr/>
-          <a:lstStyle/>
-          <a:p>
-            <a:endParaRPr lang="en-US"/>
-          </a:p>
-        </p:txBody>
+          <a:bodyPr anchor="b"/>
+          <a:lstStyle/>
+          <a:p>
+            <a:pPr algn="l"/>
+            <a:endParaRPr lang="en-US" sz="2800" b="1">
+              <a:solidFill>
+                <a:srgbClr val="1B2A4A"/>
+              </a:solidFill>
+              <a:latin typeface="+mj-lt"/>
+            </a:endParaRPr>
+          </a:p>
+        </p:txBody>
+      </p:sp>
+      <p:sp>
+        <p:nvSpPr>
+          <p:cNvPr id="5" name="Accent Line"/>
+          <p:cNvSpPr/>
+          <p:nvPr/>
+        </p:nvSpPr>
+        <p:spPr>
+          <a:xfrm>
+            <a:off x="457200" y="1828800"/>
+            <a:ext cx="11277600" cy="0"/>
+          </a:xfrm>
+          <a:prstGeom prst="line">
+            <a:avLst/>
+          </a:prstGeom>
+          <a:ln w="28575">
+            <a:solidFill>
+              <a:srgbClr val="2D7DD2"/>
+            </a:solidFill>
+          </a:ln>
+        </p:spPr>
       </p:sp>
       <p:sp>
         <p:nvSpPr>
@@ -441,10 +686,15 @@
           </a:xfrm>
         </p:spPr>
         <p:txBody>
-          <a:bodyPr/>
-          <a:lstStyle/>
-          <a:p>
-            <a:endParaRPr lang="en-US"/>
+          <a:bodyPr anchor="t"/>
+          <a:lstStyle/>
+          <a:p>
+            <a:endParaRPr lang="en-US" sz="1400">
+              <a:solidFill>
+                <a:srgbClr val="2C3E50"/>
+              </a:solidFill>
+              <a:latin typeface="+mn-lt"/>
+            </a:endParaRPr>
           </a:p>
         </p:txBody>
       </p:sp>

</xml_diff>